<commit_message>
Update the Instruction files to read-only.
</commit_message>
<xml_diff>
--- a/Instructions/Instructions for EasyChair Submission(Author)[UV2026].pptx
+++ b/Instructions/Instructions for EasyChair Submission(Author)[UV2026].pptx
@@ -379,7 +379,7 @@
           <a:p>
             <a:fld id="{0F9B84EA-7D68-4D60-9CB1-D50884785D1C}" type="datetimeFigureOut">
               <a:rPr lang="zh-CN" altLang="en-US" smtClean="0"/>
-              <a:t>2026/5/31</a:t>
+              <a:t>2026/6/6</a:t>
             </a:fld>
             <a:endParaRPr lang="zh-CN" altLang="en-US"/>
           </a:p>
@@ -12851,25 +12851,7 @@
                 <a:sym typeface="+mn-ea"/>
                 <a:hlinkClick r:id="rId5" action="ppaction://hlinksldjump"/>
               </a:rPr>
-              <a:t>【</a:t>
-            </a:r>
-            <a:r>
-              <a:rPr lang="en-GB" sz="2000" dirty="0">
-                <a:latin typeface="Times New Roman" panose="02020603050405020304" charset="0"/>
-                <a:cs typeface="Times New Roman" panose="02020603050405020304" charset="0"/>
-                <a:sym typeface="+mn-ea"/>
-                <a:hlinkClick r:id="rId5" action="ppaction://hlinksldjump"/>
-              </a:rPr>
-              <a:t>Slide</a:t>
-            </a:r>
-            <a:r>
-              <a:rPr lang="en-GB" sz="2000" dirty="0">
-                <a:latin typeface="Times New Roman" panose="02020603050405020304" charset="0"/>
-                <a:cs typeface="Times New Roman" panose="02020603050405020304" charset="0"/>
-                <a:sym typeface="+mn-ea"/>
-                <a:hlinkClick r:id="rId5" action="ppaction://hlinksldjump"/>
-              </a:rPr>
-              <a:t> 15】</a:t>
+              <a:t>【Slide 15】</a:t>
             </a:r>
             <a:endParaRPr lang="en-US" altLang="zh-CN" sz="2000" dirty="0">
               <a:latin typeface="Times New Roman" panose="02020603050405020304" charset="0"/>

</xml_diff>